<commit_message>
Online eval 22/22, update docs and slides
</commit_message>
<xml_diff>
--- a/docs/Rebooter AI นำเสนอโครงงาน.pptx
+++ b/docs/Rebooter AI นำเสนอโครงงาน.pptx
@@ -557,7 +557,7 @@
           <a:p>
             <a:r>
               <a:rPr lang="en-US" dirty="0"/>
-              <a:t>จุดปรับปรุงที่หนึ่งเจอจากการทดสอบจริง รอบแรก Llama Guard บล็อกคำถามกู้ข้อมูลและคำตอบเรื่องป๊อปอัปไวรัสปลอม เพราะมองเป็นอาชญากรรม ผมแก้ให้ผ่านเฉพาะเมื่อโมเดลให้แค่หมวด S2 ข้อความพูดถึงบริการของร้าน และไม่มีคำบ่งเจตนาโจมตี ผลจาก 20 เป็น 22 จาก 22 โดยกรณีแฮก Wi-Fi ยังถูกบล็อก จุดที่สองคือชั้นกฎของร้าน จุดที่สามคือการตรวจราคา คำตอบที่มีราคาสิบสองข้อตรงไฟล์ทั้งหมด</a:t>
+              <a:t>จุดปรับปรุงที่หนึ่งเจอจากการทดสอบจริง รอบแรก Llama Guard บล็อกคำถามกู้ข้อมูลและคำตอบเรื่องป๊อปอัปไวรัสปลอม เพราะมองเป็นอาชญากรรม ผมแก้ให้ผ่านเฉพาะเมื่อโมเดลให้แค่หมวด S2 ข้อความพูดถึงบริการของร้าน และไม่มีคำบ่งเจตนาโจมตี ผลจาก 20 เป็น 22 จาก 22 โดยกรณีแฮก Wi-Fi ยังถูกบล็อก ตอนขึ้น Render เจอแบบเดียวกันอีกสองหมวด คือ S6 กับคำแนะนำซ่อมจอฟ้า และ S7 กับเบอร์โทรร้าน แก้หลักเดียวกัน ผลออนไลน์ผ่าน 22 จาก 22 จุดที่สองคือชั้นกฎของร้าน จุดที่สามคือการตรวจราคา คำตอบที่มีราคาสิบสองข้อตรงไฟล์ทั้งหมด</a:t>
             </a:r>
           </a:p>
         </p:txBody>
@@ -731,7 +731,7 @@
           <a:p>
             <a:r>
               <a:rPr lang="en-US" dirty="0"/>
-              <a:t>ขอบคุณครับ ต่อไปเป็นเดโมระบบจริงสี่ขั้น เปิดหน้าแรกร้าน ถามราคาลง Windows ส่งภาพจอฟ้า แล้วลองขอส่วนลดให้เห็นว่าถูกปฏิเสธ ก่อนเดโมเปิด Guard และ Backend ไว้ก่อนและเช็ก /health โค้ดและผลทดสอบทั้งหมดอยู่บน GitHub ตามลิงก์ครับ</a:t>
+              <a:t>ขอบคุณครับ ต่อไปเป็นเดโมระบบจริงสี่ขั้น เปิดหน้าแรกร้าน ถามราคาลง Windows ส่งภาพจอฟ้า แล้วลองขอส่วนลดให้เห็นว่าถูกปฏิเสธ ก่อนเดโมเปิด Guard และ Backend ไว้ก่อนและเช็ก /health โค้ดและผลทดสอบทั้งหมดอยู่บน GitHub และลองใช้งานจริงได้ที่ rebooter-ai.onrender.com ครับ ถ้าเว็บหลับให้รอประมาณหนึ่งนาที</a:t>
             </a:r>
           </a:p>
         </p:txBody>
@@ -2761,7 +2761,7 @@
                 <a:ea typeface="TH Sarabun New"/>
                 <a:cs typeface="TH Sarabun New"/>
               </a:rPr>
-              <a:t>รอบแรกผ่าน 20/22</a:t>
+              <a:t>รอบแรกผ่าน 20/22 · ออนไลน์ 22/22</a:t>
             </a:r>
             <a:endParaRPr lang="en-US" sz="2850" dirty="0"/>
           </a:p>
@@ -5979,7 +5979,7 @@
                 <a:ea typeface="TH Sarabun New"/>
                 <a:cs typeface="TH Sarabun New"/>
               </a:rPr>
-              <a:t>Llama Guard บล็อกงานบริการปกติเป็นอาชญากรรม (S2)</a:t>
+              <a:t>Llama Guard บล็อกงานบริการปกติผิดหมวด (S2 · S6 · S7)</a:t>
             </a:r>
             <a:endParaRPr lang="en-US" sz="2100" dirty="0"/>
           </a:p>
@@ -6023,7 +6023,7 @@
                 <a:ea typeface="TH Sarabun New"/>
                 <a:cs typeface="TH Sarabun New"/>
               </a:rPr>
-              <a:t>“เผลอลบไฟล์ กู้ข้อมูลได้ไหม” และภาพป๊อปอัปไวรัสปลอม ถูกบล็อก → ยอมให้ผ่านเฉพาะเมื่อพูดถึงบริการร้านและไม่มีเจตนาโจมตี</a:t>
+              <a:t>กู้ข้อมูล/ป๊อปอัปไวรัส (S2), คำแนะนำซ่อมจอฟ้า (S6), เบอร์ร้าน (S7) ถูกบล็อก → ผ่านเฉพาะเรื่องของร้านที่ไม่มีสัญญาณอันตราย</a:t>
             </a:r>
             <a:endParaRPr lang="en-US" sz="1700" dirty="0"/>
           </a:p>
@@ -6575,7 +6575,7 @@
                 <a:ea typeface="TH Sarabun New"/>
                 <a:cs typeface="TH Sarabun New"/>
               </a:rPr>
-              <a:t>ข้อ 1: ยังบล็อก “แฮก Wi-Fi”, “เขียนไวรัส”, “ข้อมูลของคนอื่น” เหมือนเดิม · มี unit test 9 กรณีคุม</a:t>
+              <a:t>ข้อ 1: ยังบล็อก “แฮก Wi-Fi”, “เขียนไวรัส”, “ข้อมูลของคนอื่น” เหมือนเดิม · มี unit test 23 กรณีคุม</a:t>
             </a:r>
             <a:endParaRPr lang="en-US" sz="1700" dirty="0"/>
           </a:p>
@@ -7514,7 +7514,7 @@
                 <a:ea typeface="TH Sarabun New"/>
                 <a:cs typeface="TH Sarabun New"/>
               </a:rPr>
-              <a:t>โค้ดและผลทดสอบทั้งหมด</a:t>
+              <a:t>โค้ด ผลทดสอบ และเว็บออนไลน์</a:t>
             </a:r>
             <a:endParaRPr lang="en-US" sz="1700" dirty="0"/>
           </a:p>
@@ -7565,7 +7565,7 @@
                   </a:extLst>
                 </a:hlinkClick>
               </a:rPr>
-              <a:t>github.com/FlyingLovey/rebooter-ai-chatbot</a:t>
+              <a:t>github.com/FlyingLovey/rebooter-ai-chatbot · rebooter-ai.onrender.com</a:t>
             </a:r>
             <a:endParaRPr lang="en-US" sz="2350" dirty="0"/>
           </a:p>
@@ -9255,7 +9255,7 @@
                 <a:ea typeface="TH Sarabun New"/>
                 <a:cs typeface="TH Sarabun New"/>
               </a:rPr>
-              <a:t>หน้าเว็บ, Chat API, Pipeline, Vision, RAG (ChromaDB + multilingual-e5-small)</a:t>
+              <a:t>หน้าเว็บ, Chat API, Pipeline, Vision, RAG (ChromaDB + e5-small · บน Render ใช้ embedding API)</a:t>
             </a:r>
             <a:endParaRPr lang="en-US" sz="1700" dirty="0"/>
           </a:p>

</xml_diff>

<commit_message>
Update architecture diagram: corrected lines, larger text
</commit_message>
<xml_diff>
--- a/docs/Rebooter AI นำเสนอโครงงาน.pptx
+++ b/docs/Rebooter AI นำเสนอโครงงาน.pptx
@@ -9570,8 +9570,8 @@
         </p:blipFill>
         <p:spPr>
           <a:xfrm>
-            <a:off x="5159142" y="1771551"/>
-            <a:ext cx="5912316" cy="3924300"/>
+            <a:off x="5159142" y="2066756"/>
+            <a:ext cx="5912316" cy="3333889"/>
           </a:xfrm>
           <a:prstGeom prst="rect">
             <a:avLst/>

</xml_diff>